<commit_message>
update paper for lecture 1
</commit_message>
<xml_diff>
--- a/papers/lektion-1.pptx
+++ b/papers/lektion-1.pptx
@@ -266,7 +266,7 @@
           <a:p>
             <a:fld id="{FC23D672-218E-44CF-A13C-71AB61B14F4F}" type="datetimeFigureOut">
               <a:rPr lang="de-CH" smtClean="0"/>
-              <a:t>19.01.2025</a:t>
+              <a:t>16.01.2026</a:t>
             </a:fld>
             <a:endParaRPr lang="de-CH"/>
           </a:p>
@@ -431,7 +431,7 @@
           <a:p>
             <a:fld id="{93FA598B-8DA1-4BBA-9EA9-DC1615E9868A}" type="datetimeFigureOut">
               <a:rPr lang="de-CH" smtClean="0"/>
-              <a:t>19.01.2025</a:t>
+              <a:t>16.01.2026</a:t>
             </a:fld>
             <a:endParaRPr lang="de-CH"/>
           </a:p>
@@ -1839,6 +1839,10 @@
           <a:bodyPr/>
           <a:lstStyle/>
           <a:p>
+            <a:r>
+              <a:rPr lang="de-CH" dirty="0"/>
+              <a:t>Frontend &lt;-&gt; Backend</a:t>
+            </a:r>
             <a:endParaRPr lang="LID4096" dirty="0"/>
           </a:p>
         </p:txBody>
@@ -2081,7 +2085,7 @@
           <a:p>
             <a:fld id="{6853F526-C1D0-4550-B781-F5C2F41E5AD9}" type="datetime1">
               <a:rPr lang="de-CH" smtClean="0"/>
-              <a:t>19.01.2025</a:t>
+              <a:t>16.01.2026</a:t>
             </a:fld>
             <a:endParaRPr lang="de-CH"/>
           </a:p>
@@ -2217,7 +2221,7 @@
           <a:p>
             <a:fld id="{A1523D7E-84BA-4532-8AC0-0461707F3C45}" type="datetime1">
               <a:rPr lang="de-CH" smtClean="0"/>
-              <a:t>19.01.2025</a:t>
+              <a:t>16.01.2026</a:t>
             </a:fld>
             <a:endParaRPr lang="de-CH"/>
           </a:p>
@@ -2845,7 +2849,7 @@
           <a:p>
             <a:fld id="{107B2E98-33F3-4843-92CD-A9A795F13784}" type="datetime1">
               <a:rPr lang="de-CH" smtClean="0"/>
-              <a:t>19.01.2025</a:t>
+              <a:t>16.01.2026</a:t>
             </a:fld>
             <a:endParaRPr lang="de-CH"/>
           </a:p>
@@ -3106,7 +3110,7 @@
           <a:p>
             <a:fld id="{EDD8499C-A6CC-4B08-A018-E3879373337C}" type="datetimeFigureOut">
               <a:rPr lang="de-CH" smtClean="0"/>
-              <a:t>19.01.2025</a:t>
+              <a:t>16.01.2026</a:t>
             </a:fld>
             <a:endParaRPr lang="de-CH"/>
           </a:p>
@@ -3247,7 +3251,7 @@
           <a:p>
             <a:fld id="{A1523D7E-84BA-4532-8AC0-0461707F3C45}" type="datetime1">
               <a:rPr lang="de-CH" smtClean="0"/>
-              <a:t>19.01.2025</a:t>
+              <a:t>16.01.2026</a:t>
             </a:fld>
             <a:endParaRPr lang="de-CH"/>
           </a:p>
@@ -3889,7 +3893,7 @@
           <a:p>
             <a:fld id="{6853F526-C1D0-4550-B781-F5C2F41E5AD9}" type="datetime1">
               <a:rPr lang="de-CH" smtClean="0"/>
-              <a:t>19.01.2025</a:t>
+              <a:t>16.01.2026</a:t>
             </a:fld>
             <a:endParaRPr lang="de-CH"/>
           </a:p>
@@ -4025,7 +4029,7 @@
           <a:p>
             <a:fld id="{A1523D7E-84BA-4532-8AC0-0461707F3C45}" type="datetime1">
               <a:rPr lang="de-CH" smtClean="0"/>
-              <a:t>19.01.2025</a:t>
+              <a:t>16.01.2026</a:t>
             </a:fld>
             <a:endParaRPr lang="de-CH"/>
           </a:p>
@@ -4268,7 +4272,7 @@
           <a:p>
             <a:fld id="{A1523D7E-84BA-4532-8AC0-0461707F3C45}" type="datetime1">
               <a:rPr lang="de-CH" smtClean="0"/>
-              <a:t>19.01.2025</a:t>
+              <a:t>16.01.2026</a:t>
             </a:fld>
             <a:endParaRPr lang="de-CH"/>
           </a:p>
@@ -4632,7 +4636,7 @@
           <a:p>
             <a:fld id="{0F06BCF4-0E81-4303-B76F-6C3D6B7E70BE}" type="datetime1">
               <a:rPr lang="de-CH" smtClean="0"/>
-              <a:t>19.01.2025</a:t>
+              <a:t>16.01.2026</a:t>
             </a:fld>
             <a:endParaRPr lang="de-CH"/>
           </a:p>
@@ -4756,7 +4760,7 @@
           <a:p>
             <a:fld id="{A1523D7E-84BA-4532-8AC0-0461707F3C45}" type="datetime1">
               <a:rPr lang="de-CH" smtClean="0"/>
-              <a:t>19.01.2025</a:t>
+              <a:t>16.01.2026</a:t>
             </a:fld>
             <a:endParaRPr lang="de-CH"/>
           </a:p>
@@ -4914,7 +4918,7 @@
           <a:p>
             <a:fld id="{A1523D7E-84BA-4532-8AC0-0461707F3C45}" type="datetime1">
               <a:rPr lang="de-CH" smtClean="0"/>
-              <a:t>19.01.2025</a:t>
+              <a:t>16.01.2026</a:t>
             </a:fld>
             <a:endParaRPr lang="de-CH"/>
           </a:p>
@@ -5160,7 +5164,7 @@
             <a:fld id="{A1523D7E-84BA-4532-8AC0-0461707F3C45}" type="datetime1">
               <a:rPr lang="de-CH" smtClean="0"/>
               <a:pPr/>
-              <a:t>19.01.2025</a:t>
+              <a:t>16.01.2026</a:t>
             </a:fld>
             <a:endParaRPr lang="de-CH" dirty="0"/>
           </a:p>
@@ -5724,7 +5728,7 @@
           <a:p>
             <a:r>
               <a:rPr lang="de-CH" dirty="0"/>
-              <a:t>20.01.2025</a:t>
+              <a:t>19.01.2026</a:t>
             </a:r>
           </a:p>
         </p:txBody>
@@ -7331,7 +7335,7 @@
               <a:rPr lang="de-CH" dirty="0">
                 <a:hlinkClick r:id="rId2"/>
               </a:rPr>
-              <a:t>https://api3.geo.admin.ch/services/sdiservices.html</a:t>
+              <a:t>https://docs.geo.admin.ch/get-started/overview.html</a:t>
             </a:r>
             <a:endParaRPr lang="de-CH" dirty="0"/>
           </a:p>
@@ -7347,24 +7351,30 @@
           <a:p>
             <a:pPr lvl="1"/>
             <a:r>
-              <a:rPr lang="de-CH" dirty="0" err="1"/>
-              <a:t>MapServer</a:t>
+              <a:rPr lang="de-CH" dirty="0">
+                <a:hlinkClick r:id="rId3"/>
+              </a:rPr>
+              <a:t>Search</a:t>
             </a:r>
             <a:endParaRPr lang="de-CH" dirty="0"/>
           </a:p>
           <a:p>
             <a:pPr lvl="1"/>
             <a:r>
-              <a:rPr lang="de-CH" dirty="0" err="1"/>
-              <a:t>SearchServer</a:t>
+              <a:rPr lang="de-CH" dirty="0">
+                <a:hlinkClick r:id="rId4"/>
+              </a:rPr>
+              <a:t>Height</a:t>
             </a:r>
             <a:endParaRPr lang="de-CH" dirty="0"/>
           </a:p>
           <a:p>
             <a:pPr lvl="1"/>
             <a:r>
-              <a:rPr lang="de-CH" dirty="0"/>
-              <a:t>Height </a:t>
+              <a:rPr lang="de-CH" dirty="0">
+                <a:hlinkClick r:id="rId5"/>
+              </a:rPr>
+              <a:t>Features</a:t>
             </a:r>
             <a:endParaRPr lang="LID4096" dirty="0"/>
           </a:p>

</xml_diff>

<commit_message>
update papers for lecture 1
</commit_message>
<xml_diff>
--- a/papers/lektion-1.pptx
+++ b/papers/lektion-1.pptx
@@ -266,7 +266,7 @@
           <a:p>
             <a:fld id="{FC23D672-218E-44CF-A13C-71AB61B14F4F}" type="datetimeFigureOut">
               <a:rPr lang="de-CH" smtClean="0"/>
-              <a:t>16.01.2026</a:t>
+              <a:t>19.01.2026</a:t>
             </a:fld>
             <a:endParaRPr lang="de-CH"/>
           </a:p>
@@ -431,7 +431,7 @@
           <a:p>
             <a:fld id="{93FA598B-8DA1-4BBA-9EA9-DC1615E9868A}" type="datetimeFigureOut">
               <a:rPr lang="de-CH" smtClean="0"/>
-              <a:t>16.01.2026</a:t>
+              <a:t>19.01.2026</a:t>
             </a:fld>
             <a:endParaRPr lang="de-CH"/>
           </a:p>
@@ -2085,7 +2085,7 @@
           <a:p>
             <a:fld id="{6853F526-C1D0-4550-B781-F5C2F41E5AD9}" type="datetime1">
               <a:rPr lang="de-CH" smtClean="0"/>
-              <a:t>16.01.2026</a:t>
+              <a:t>19.01.2026</a:t>
             </a:fld>
             <a:endParaRPr lang="de-CH"/>
           </a:p>
@@ -2221,7 +2221,7 @@
           <a:p>
             <a:fld id="{A1523D7E-84BA-4532-8AC0-0461707F3C45}" type="datetime1">
               <a:rPr lang="de-CH" smtClean="0"/>
-              <a:t>16.01.2026</a:t>
+              <a:t>19.01.2026</a:t>
             </a:fld>
             <a:endParaRPr lang="de-CH"/>
           </a:p>
@@ -2849,7 +2849,7 @@
           <a:p>
             <a:fld id="{107B2E98-33F3-4843-92CD-A9A795F13784}" type="datetime1">
               <a:rPr lang="de-CH" smtClean="0"/>
-              <a:t>16.01.2026</a:t>
+              <a:t>19.01.2026</a:t>
             </a:fld>
             <a:endParaRPr lang="de-CH"/>
           </a:p>
@@ -3110,7 +3110,7 @@
           <a:p>
             <a:fld id="{EDD8499C-A6CC-4B08-A018-E3879373337C}" type="datetimeFigureOut">
               <a:rPr lang="de-CH" smtClean="0"/>
-              <a:t>16.01.2026</a:t>
+              <a:t>19.01.2026</a:t>
             </a:fld>
             <a:endParaRPr lang="de-CH"/>
           </a:p>
@@ -3251,7 +3251,7 @@
           <a:p>
             <a:fld id="{A1523D7E-84BA-4532-8AC0-0461707F3C45}" type="datetime1">
               <a:rPr lang="de-CH" smtClean="0"/>
-              <a:t>16.01.2026</a:t>
+              <a:t>19.01.2026</a:t>
             </a:fld>
             <a:endParaRPr lang="de-CH"/>
           </a:p>
@@ -3893,7 +3893,7 @@
           <a:p>
             <a:fld id="{6853F526-C1D0-4550-B781-F5C2F41E5AD9}" type="datetime1">
               <a:rPr lang="de-CH" smtClean="0"/>
-              <a:t>16.01.2026</a:t>
+              <a:t>19.01.2026</a:t>
             </a:fld>
             <a:endParaRPr lang="de-CH"/>
           </a:p>
@@ -4029,7 +4029,7 @@
           <a:p>
             <a:fld id="{A1523D7E-84BA-4532-8AC0-0461707F3C45}" type="datetime1">
               <a:rPr lang="de-CH" smtClean="0"/>
-              <a:t>16.01.2026</a:t>
+              <a:t>19.01.2026</a:t>
             </a:fld>
             <a:endParaRPr lang="de-CH"/>
           </a:p>
@@ -4272,7 +4272,7 @@
           <a:p>
             <a:fld id="{A1523D7E-84BA-4532-8AC0-0461707F3C45}" type="datetime1">
               <a:rPr lang="de-CH" smtClean="0"/>
-              <a:t>16.01.2026</a:t>
+              <a:t>19.01.2026</a:t>
             </a:fld>
             <a:endParaRPr lang="de-CH"/>
           </a:p>
@@ -4636,7 +4636,7 @@
           <a:p>
             <a:fld id="{0F06BCF4-0E81-4303-B76F-6C3D6B7E70BE}" type="datetime1">
               <a:rPr lang="de-CH" smtClean="0"/>
-              <a:t>16.01.2026</a:t>
+              <a:t>19.01.2026</a:t>
             </a:fld>
             <a:endParaRPr lang="de-CH"/>
           </a:p>
@@ -4760,7 +4760,7 @@
           <a:p>
             <a:fld id="{A1523D7E-84BA-4532-8AC0-0461707F3C45}" type="datetime1">
               <a:rPr lang="de-CH" smtClean="0"/>
-              <a:t>16.01.2026</a:t>
+              <a:t>19.01.2026</a:t>
             </a:fld>
             <a:endParaRPr lang="de-CH"/>
           </a:p>
@@ -4918,7 +4918,7 @@
           <a:p>
             <a:fld id="{A1523D7E-84BA-4532-8AC0-0461707F3C45}" type="datetime1">
               <a:rPr lang="de-CH" smtClean="0"/>
-              <a:t>16.01.2026</a:t>
+              <a:t>19.01.2026</a:t>
             </a:fld>
             <a:endParaRPr lang="de-CH"/>
           </a:p>
@@ -5164,7 +5164,7 @@
             <a:fld id="{A1523D7E-84BA-4532-8AC0-0461707F3C45}" type="datetime1">
               <a:rPr lang="de-CH" smtClean="0"/>
               <a:pPr/>
-              <a:t>16.01.2026</a:t>
+              <a:t>19.01.2026</a:t>
             </a:fld>
             <a:endParaRPr lang="de-CH" dirty="0"/>
           </a:p>
@@ -6496,7 +6496,7 @@
           <a:p>
             <a:r>
               <a:rPr lang="de-CH" dirty="0"/>
-              <a:t>Repository erstellen</a:t>
+              <a:t>Git Repository erstellen</a:t>
             </a:r>
           </a:p>
           <a:p>
@@ -8704,7 +8704,7 @@
             </a:pPr>
             <a:r>
               <a:rPr lang="de-CH" dirty="0"/>
-              <a:t>Seit 4 Jahren Software</a:t>
+              <a:t>Seit 5 Jahren Software</a:t>
             </a:r>
             <a:br>
               <a:rPr lang="de-CH" dirty="0"/>
@@ -8728,24 +8728,7 @@
             </a:pPr>
             <a:r>
               <a:rPr lang="de-CH" dirty="0"/>
-              <a:t>Seit 2 Jahren BFO Lehrperson</a:t>
-            </a:r>
-          </a:p>
-          <a:p>
-            <a:pPr>
-              <a:lnSpc>
-                <a:spcPct val="110000"/>
-              </a:lnSpc>
-              <a:spcBef>
-                <a:spcPts val="300"/>
-              </a:spcBef>
-              <a:spcAft>
-                <a:spcPts val="800"/>
-              </a:spcAft>
-            </a:pPr>
-            <a:r>
-              <a:rPr lang="de-CH" dirty="0"/>
-              <a:t>Dieses Modul zum ersten Mal </a:t>
+              <a:t>Seit 3 Jahren BFO Lehrperson </a:t>
             </a:r>
             <a:endParaRPr lang="LID4096" dirty="0"/>
           </a:p>
@@ -8945,55 +8928,6 @@
                                           <p:spTgt spid="9">
                                             <p:txEl>
                                               <p:pRg st="3" end="3"/>
-                                            </p:txEl>
-                                          </p:spTgt>
-                                        </p:tgtEl>
-                                        <p:attrNameLst>
-                                          <p:attrName>style.visibility</p:attrName>
-                                        </p:attrNameLst>
-                                      </p:cBhvr>
-                                      <p:to>
-                                        <p:strVal val="visible"/>
-                                      </p:to>
-                                    </p:set>
-                                  </p:childTnLst>
-                                </p:cTn>
-                              </p:par>
-                            </p:childTnLst>
-                          </p:cTn>
-                        </p:par>
-                      </p:childTnLst>
-                    </p:cTn>
-                  </p:par>
-                  <p:par>
-                    <p:cTn id="19" fill="hold">
-                      <p:stCondLst>
-                        <p:cond delay="indefinite"/>
-                      </p:stCondLst>
-                      <p:childTnLst>
-                        <p:par>
-                          <p:cTn id="20" fill="hold">
-                            <p:stCondLst>
-                              <p:cond delay="0"/>
-                            </p:stCondLst>
-                            <p:childTnLst>
-                              <p:par>
-                                <p:cTn id="21" presetID="1" presetClass="entr" presetSubtype="0" fill="hold" grpId="0" nodeType="clickEffect">
-                                  <p:stCondLst>
-                                    <p:cond delay="0"/>
-                                  </p:stCondLst>
-                                  <p:childTnLst>
-                                    <p:set>
-                                      <p:cBhvr>
-                                        <p:cTn id="22" dur="1" fill="hold">
-                                          <p:stCondLst>
-                                            <p:cond delay="0"/>
-                                          </p:stCondLst>
-                                        </p:cTn>
-                                        <p:tgtEl>
-                                          <p:spTgt spid="9">
-                                            <p:txEl>
-                                              <p:pRg st="4" end="4"/>
                                             </p:txEl>
                                           </p:spTgt>
                                         </p:tgtEl>
@@ -11404,15 +11338,12 @@
 </file>
 
 <file path=customXml/item1.xml><?xml version="1.0" encoding="utf-8"?>
-<p:properties xmlns:p="http://schemas.microsoft.com/office/2006/metadata/properties" xmlns:xsi="http://www.w3.org/2001/XMLSchema-instance" xmlns:pc="http://schemas.microsoft.com/office/infopath/2007/PartnerControls">
-  <documentManagement>
-    <MediaLengthInSeconds xmlns="1dbf6c8a-8f63-44bb-83c7-9ba9b5d4efe9" xsi:nil="true"/>
-    <lcf76f155ced4ddcb4097134ff3c332f xmlns="1dbf6c8a-8f63-44bb-83c7-9ba9b5d4efe9">
-      <Terms xmlns="http://schemas.microsoft.com/office/infopath/2007/PartnerControls"/>
-    </lcf76f155ced4ddcb4097134ff3c332f>
-    <TaxCatchAll xmlns="06172d57-5d51-4d29-806c-4b74cd929571" xsi:nil="true"/>
-  </documentManagement>
-</p:properties>
+<?mso-contentType ?>
+<FormTemplates xmlns="http://schemas.microsoft.com/sharepoint/v3/contenttype/forms">
+  <Display>DocumentLibraryForm</Display>
+  <Edit>DocumentLibraryForm</Edit>
+  <New>DocumentLibraryForm</New>
+</FormTemplates>
 </file>
 
 <file path=customXml/item2.xml><?xml version="1.0" encoding="utf-8"?>
@@ -11645,21 +11576,21 @@
 </file>
 
 <file path=customXml/item3.xml><?xml version="1.0" encoding="utf-8"?>
-<?mso-contentType ?>
-<FormTemplates xmlns="http://schemas.microsoft.com/sharepoint/v3/contenttype/forms">
-  <Display>DocumentLibraryForm</Display>
-  <Edit>DocumentLibraryForm</Edit>
-  <New>DocumentLibraryForm</New>
-</FormTemplates>
+<p:properties xmlns:p="http://schemas.microsoft.com/office/2006/metadata/properties" xmlns:xsi="http://www.w3.org/2001/XMLSchema-instance" xmlns:pc="http://schemas.microsoft.com/office/infopath/2007/PartnerControls">
+  <documentManagement>
+    <MediaLengthInSeconds xmlns="1dbf6c8a-8f63-44bb-83c7-9ba9b5d4efe9" xsi:nil="true"/>
+    <lcf76f155ced4ddcb4097134ff3c332f xmlns="1dbf6c8a-8f63-44bb-83c7-9ba9b5d4efe9">
+      <Terms xmlns="http://schemas.microsoft.com/office/infopath/2007/PartnerControls"/>
+    </lcf76f155ced4ddcb4097134ff3c332f>
+    <TaxCatchAll xmlns="06172d57-5d51-4d29-806c-4b74cd929571" xsi:nil="true"/>
+  </documentManagement>
+</p:properties>
 </file>
 
 <file path=customXml/itemProps1.xml><?xml version="1.0" encoding="utf-8"?>
-<ds:datastoreItem xmlns:ds="http://schemas.openxmlformats.org/officeDocument/2006/customXml" ds:itemID="{C75C5BEF-A826-4D32-BB75-8169F3E7AF17}">
+<ds:datastoreItem xmlns:ds="http://schemas.openxmlformats.org/officeDocument/2006/customXml" ds:itemID="{1AE3F8FF-813C-4132-BE80-C573B634B911}">
   <ds:schemaRefs>
-    <ds:schemaRef ds:uri="http://schemas.microsoft.com/office/2006/metadata/properties"/>
-    <ds:schemaRef ds:uri="http://schemas.microsoft.com/office/infopath/2007/PartnerControls"/>
-    <ds:schemaRef ds:uri="1dbf6c8a-8f63-44bb-83c7-9ba9b5d4efe9"/>
-    <ds:schemaRef ds:uri="06172d57-5d51-4d29-806c-4b74cd929571"/>
+    <ds:schemaRef ds:uri="http://schemas.microsoft.com/sharepoint/v3/contenttype/forms"/>
   </ds:schemaRefs>
 </ds:datastoreItem>
 </file>
@@ -11684,9 +11615,12 @@
 </file>
 
 <file path=customXml/itemProps3.xml><?xml version="1.0" encoding="utf-8"?>
-<ds:datastoreItem xmlns:ds="http://schemas.openxmlformats.org/officeDocument/2006/customXml" ds:itemID="{1AE3F8FF-813C-4132-BE80-C573B634B911}">
+<ds:datastoreItem xmlns:ds="http://schemas.openxmlformats.org/officeDocument/2006/customXml" ds:itemID="{C75C5BEF-A826-4D32-BB75-8169F3E7AF17}">
   <ds:schemaRefs>
-    <ds:schemaRef ds:uri="http://schemas.microsoft.com/sharepoint/v3/contenttype/forms"/>
+    <ds:schemaRef ds:uri="http://schemas.microsoft.com/office/2006/metadata/properties"/>
+    <ds:schemaRef ds:uri="http://schemas.microsoft.com/office/infopath/2007/PartnerControls"/>
+    <ds:schemaRef ds:uri="1dbf6c8a-8f63-44bb-83c7-9ba9b5d4efe9"/>
+    <ds:schemaRef ds:uri="06172d57-5d51-4d29-806c-4b74cd929571"/>
   </ds:schemaRefs>
 </ds:datastoreItem>
 </file>
</xml_diff>